<commit_message>
Ajusta business plan: remove menções a produção e reconstrução
- Reposiciona maturidade como "MVP construído e testado, pronto para
  piloto" (pré-lançamento), sem alegar uso em produção.
- Remove todas as referências à reconstrução do código (SWOT, riscos,
  status do produto, slides de produto/tese).
- Substitui o risco de "titularidade do código" por "product-market fit
  não comprovado", coerente com o estágio.
- Renomeia scripts de geração para .cjs (compatíveis com o pacote ESM da
  raiz) e adiciona package.json + .gitignore da pasta.

Co-Authored-By: Claude Opus 4.8 <noreply@anthropic.com>
</commit_message>
<xml_diff>
--- a/business-plan/HealthMatch_Pitch_Deck.pptx
+++ b/business-plan/HealthMatch_Pitch_Deck.pptx
@@ -6375,7 +6375,7 @@
                 <a:ea typeface="Arial" pitchFamily="34" charset="-122"/>
                 <a:cs typeface="Arial" pitchFamily="34" charset="-120"/>
               </a:rPr>
-              <a:t>já validado em produção, base de código auditada</a:t>
+              <a:t>construído e testado, pronto para implantar</a:t>
             </a:r>
             <a:endParaRPr lang="en-US" sz="1150" dirty="0"/>
           </a:p>
@@ -9048,7 +9048,7 @@
                 <a:ea typeface="Arial" pitchFamily="34" charset="-122"/>
                 <a:cs typeface="Arial" pitchFamily="34" charset="-120"/>
               </a:rPr>
-              <a:t>Não é protótipo: o produto já operou em produção</a:t>
+              <a:t>Não é uma ideia: o produto já está construído e testado</a:t>
             </a:r>
             <a:endParaRPr lang="en-US" sz="3000" dirty="0"/>
           </a:p>
@@ -9394,7 +9394,7 @@
                 <a:ea typeface="Arial" pitchFamily="34" charset="-122"/>
                 <a:cs typeface="Arial" pitchFamily="34" charset="-120"/>
               </a:rPr>
-              <a:t>1:1</a:t>
+              <a:t>Pronto</a:t>
             </a:r>
             <a:endParaRPr lang="en-US" sz="2600" dirty="0"/>
           </a:p>
@@ -9433,7 +9433,7 @@
                 <a:ea typeface="Arial" pitchFamily="34" charset="-122"/>
                 <a:cs typeface="Arial" pitchFamily="34" charset="-120"/>
               </a:rPr>
-              <a:t>paridade com a produção anterior</a:t>
+              <a:t>para o primeiro piloto</a:t>
             </a:r>
             <a:endParaRPr lang="en-US" sz="1300" dirty="0"/>
           </a:p>

</xml_diff>